<commit_message>
Deploy website - based on a98b29e268eb702eecda2550418a5d796a4eb0d5
</commit_message>
<xml_diff>
--- a/img/develop/alpha-release/ggc-architecture.pptx
+++ b/img/develop/alpha-release/ggc-architecture.pptx
@@ -104,6 +104,11 @@
       </a:defRPr>
     </a:lvl9pPr>
   </p:defaultTextStyle>
+  <p:extLst>
+    <p:ext uri="{EFAFB233-063F-42B5-8137-9DF3F51BA10A}">
+      <p15:sldGuideLst xmlns:p15="http://schemas.microsoft.com/office/powerpoint/2012/main"/>
+    </p:ext>
+  </p:extLst>
 </p:presentation>
 </file>
 
@@ -3339,7 +3344,7 @@
         </p:nvSpPr>
         <p:spPr>
           <a:xfrm>
-            <a:off x="-312895" y="5773645"/>
+            <a:off x="-312895" y="5952784"/>
             <a:ext cx="1973079" cy="644142"/>
           </a:xfrm>
           <a:ln w="25400">
@@ -3371,8 +3376,8 @@
         </p:nvSpPr>
         <p:spPr>
           <a:xfrm>
-            <a:off x="1302327" y="5468063"/>
-            <a:ext cx="10058400" cy="1191491"/>
+            <a:off x="1302327" y="5773645"/>
+            <a:ext cx="10058400" cy="885909"/>
           </a:xfrm>
           <a:prstGeom prst="rect">
             <a:avLst/>
@@ -3419,8 +3424,8 @@
         </p:nvSpPr>
         <p:spPr>
           <a:xfrm>
-            <a:off x="1302327" y="198447"/>
-            <a:ext cx="10058400" cy="4595226"/>
+            <a:off x="1302327" y="578069"/>
+            <a:ext cx="10058400" cy="4215604"/>
           </a:xfrm>
           <a:prstGeom prst="rect">
             <a:avLst/>
@@ -3469,7 +3474,7 @@
         </p:nvSpPr>
         <p:spPr>
           <a:xfrm>
-            <a:off x="-301203" y="2315417"/>
+            <a:off x="-378212" y="2587642"/>
             <a:ext cx="1973079" cy="644142"/>
           </a:xfrm>
           <a:prstGeom prst="rect">
@@ -3673,7 +3678,7 @@
         <p:spPr>
           <a:xfrm>
             <a:off x="6082145" y="4793673"/>
-            <a:ext cx="0" cy="674390"/>
+            <a:ext cx="1090" cy="979972"/>
           </a:xfrm>
           <a:prstGeom prst="straightConnector1">
             <a:avLst/>
@@ -3717,7 +3722,7 @@
         </p:nvSpPr>
         <p:spPr>
           <a:xfrm>
-            <a:off x="5733472" y="4877396"/>
+            <a:off x="5735392" y="5066875"/>
             <a:ext cx="1973079" cy="644142"/>
           </a:xfrm>
           <a:prstGeom prst="rect">
@@ -3919,7 +3924,7 @@
         </p:nvSpPr>
         <p:spPr>
           <a:xfrm>
-            <a:off x="1728593" y="5983910"/>
+            <a:off x="1660184" y="5975262"/>
             <a:ext cx="1648691" cy="481492"/>
           </a:xfrm>
           <a:prstGeom prst="rect">
@@ -4943,10 +4948,10 @@
         </p:nvGrpSpPr>
         <p:grpSpPr>
           <a:xfrm>
-            <a:off x="1444320" y="3484732"/>
-            <a:ext cx="9508521" cy="1191491"/>
-            <a:chOff x="1616679" y="2109354"/>
-            <a:chExt cx="9508521" cy="1191491"/>
+            <a:off x="1594867" y="3778238"/>
+            <a:ext cx="9396607" cy="757546"/>
+            <a:chOff x="1728593" y="2109355"/>
+            <a:chExt cx="9396607" cy="757546"/>
           </a:xfrm>
         </p:grpSpPr>
         <p:sp>
@@ -4963,8 +4968,8 @@
           </p:nvSpPr>
           <p:spPr>
             <a:xfrm>
-              <a:off x="1728593" y="2109354"/>
-              <a:ext cx="9396607" cy="1191491"/>
+              <a:off x="1728593" y="2109355"/>
+              <a:ext cx="9396607" cy="757546"/>
             </a:xfrm>
             <a:prstGeom prst="rect">
               <a:avLst/>
@@ -4999,208 +5004,6 @@
         </p:sp>
         <p:sp>
           <p:nvSpPr>
-            <p:cNvPr id="18" name="Subtitle 2">
-              <a:extLst>
-                <a:ext uri="{FF2B5EF4-FFF2-40B4-BE49-F238E27FC236}">
-                  <a16:creationId xmlns:a16="http://schemas.microsoft.com/office/drawing/2014/main" id="{BA601FF9-7F45-50C0-B8F6-AB61A76BC75E}"/>
-                </a:ext>
-              </a:extLst>
-            </p:cNvPr>
-            <p:cNvSpPr txBox="1">
-              <a:spLocks/>
-            </p:cNvSpPr>
-            <p:nvPr/>
-          </p:nvSpPr>
-          <p:spPr>
-            <a:xfrm>
-              <a:off x="1616679" y="2163064"/>
-              <a:ext cx="2699907" cy="515941"/>
-            </a:xfrm>
-            <a:prstGeom prst="rect">
-              <a:avLst/>
-            </a:prstGeom>
-            <a:ln w="25400">
-              <a:noFill/>
-            </a:ln>
-          </p:spPr>
-          <p:txBody>
-            <a:bodyPr vert="horz" lIns="91440" tIns="45720" rIns="91440" bIns="45720" rtlCol="0">
-              <a:normAutofit/>
-            </a:bodyPr>
-            <a:lstStyle>
-              <a:lvl1pPr marL="0" indent="0" algn="ctr" defTabSz="914400" rtl="0" eaLnBrk="1" latinLnBrk="0" hangingPunct="1">
-                <a:lnSpc>
-                  <a:spcPct val="90000"/>
-                </a:lnSpc>
-                <a:spcBef>
-                  <a:spcPts val="1000"/>
-                </a:spcBef>
-                <a:buFont typeface="Arial" panose="020B0604020202020204" pitchFamily="34" charset="0"/>
-                <a:buNone/>
-                <a:defRPr sz="2400" kern="1200">
-                  <a:solidFill>
-                    <a:schemeClr val="tx1"/>
-                  </a:solidFill>
-                  <a:latin typeface="+mn-lt"/>
-                  <a:ea typeface="+mn-ea"/>
-                  <a:cs typeface="+mn-cs"/>
-                </a:defRPr>
-              </a:lvl1pPr>
-              <a:lvl2pPr marL="457200" indent="0" algn="ctr" defTabSz="914400" rtl="0" eaLnBrk="1" latinLnBrk="0" hangingPunct="1">
-                <a:lnSpc>
-                  <a:spcPct val="90000"/>
-                </a:lnSpc>
-                <a:spcBef>
-                  <a:spcPts val="500"/>
-                </a:spcBef>
-                <a:buFont typeface="Arial" panose="020B0604020202020204" pitchFamily="34" charset="0"/>
-                <a:buNone/>
-                <a:defRPr sz="2000" kern="1200">
-                  <a:solidFill>
-                    <a:schemeClr val="tx1"/>
-                  </a:solidFill>
-                  <a:latin typeface="+mn-lt"/>
-                  <a:ea typeface="+mn-ea"/>
-                  <a:cs typeface="+mn-cs"/>
-                </a:defRPr>
-              </a:lvl2pPr>
-              <a:lvl3pPr marL="914400" indent="0" algn="ctr" defTabSz="914400" rtl="0" eaLnBrk="1" latinLnBrk="0" hangingPunct="1">
-                <a:lnSpc>
-                  <a:spcPct val="90000"/>
-                </a:lnSpc>
-                <a:spcBef>
-                  <a:spcPts val="500"/>
-                </a:spcBef>
-                <a:buFont typeface="Arial" panose="020B0604020202020204" pitchFamily="34" charset="0"/>
-                <a:buNone/>
-                <a:defRPr sz="1800" kern="1200">
-                  <a:solidFill>
-                    <a:schemeClr val="tx1"/>
-                  </a:solidFill>
-                  <a:latin typeface="+mn-lt"/>
-                  <a:ea typeface="+mn-ea"/>
-                  <a:cs typeface="+mn-cs"/>
-                </a:defRPr>
-              </a:lvl3pPr>
-              <a:lvl4pPr marL="1371600" indent="0" algn="ctr" defTabSz="914400" rtl="0" eaLnBrk="1" latinLnBrk="0" hangingPunct="1">
-                <a:lnSpc>
-                  <a:spcPct val="90000"/>
-                </a:lnSpc>
-                <a:spcBef>
-                  <a:spcPts val="500"/>
-                </a:spcBef>
-                <a:buFont typeface="Arial" panose="020B0604020202020204" pitchFamily="34" charset="0"/>
-                <a:buNone/>
-                <a:defRPr sz="1600" kern="1200">
-                  <a:solidFill>
-                    <a:schemeClr val="tx1"/>
-                  </a:solidFill>
-                  <a:latin typeface="+mn-lt"/>
-                  <a:ea typeface="+mn-ea"/>
-                  <a:cs typeface="+mn-cs"/>
-                </a:defRPr>
-              </a:lvl4pPr>
-              <a:lvl5pPr marL="1828800" indent="0" algn="ctr" defTabSz="914400" rtl="0" eaLnBrk="1" latinLnBrk="0" hangingPunct="1">
-                <a:lnSpc>
-                  <a:spcPct val="90000"/>
-                </a:lnSpc>
-                <a:spcBef>
-                  <a:spcPts val="500"/>
-                </a:spcBef>
-                <a:buFont typeface="Arial" panose="020B0604020202020204" pitchFamily="34" charset="0"/>
-                <a:buNone/>
-                <a:defRPr sz="1600" kern="1200">
-                  <a:solidFill>
-                    <a:schemeClr val="tx1"/>
-                  </a:solidFill>
-                  <a:latin typeface="+mn-lt"/>
-                  <a:ea typeface="+mn-ea"/>
-                  <a:cs typeface="+mn-cs"/>
-                </a:defRPr>
-              </a:lvl5pPr>
-              <a:lvl6pPr marL="2286000" indent="0" algn="ctr" defTabSz="914400" rtl="0" eaLnBrk="1" latinLnBrk="0" hangingPunct="1">
-                <a:lnSpc>
-                  <a:spcPct val="90000"/>
-                </a:lnSpc>
-                <a:spcBef>
-                  <a:spcPts val="500"/>
-                </a:spcBef>
-                <a:buFont typeface="Arial" panose="020B0604020202020204" pitchFamily="34" charset="0"/>
-                <a:buNone/>
-                <a:defRPr sz="1600" kern="1200">
-                  <a:solidFill>
-                    <a:schemeClr val="tx1"/>
-                  </a:solidFill>
-                  <a:latin typeface="+mn-lt"/>
-                  <a:ea typeface="+mn-ea"/>
-                  <a:cs typeface="+mn-cs"/>
-                </a:defRPr>
-              </a:lvl6pPr>
-              <a:lvl7pPr marL="2743200" indent="0" algn="ctr" defTabSz="914400" rtl="0" eaLnBrk="1" latinLnBrk="0" hangingPunct="1">
-                <a:lnSpc>
-                  <a:spcPct val="90000"/>
-                </a:lnSpc>
-                <a:spcBef>
-                  <a:spcPts val="500"/>
-                </a:spcBef>
-                <a:buFont typeface="Arial" panose="020B0604020202020204" pitchFamily="34" charset="0"/>
-                <a:buNone/>
-                <a:defRPr sz="1600" kern="1200">
-                  <a:solidFill>
-                    <a:schemeClr val="tx1"/>
-                  </a:solidFill>
-                  <a:latin typeface="+mn-lt"/>
-                  <a:ea typeface="+mn-ea"/>
-                  <a:cs typeface="+mn-cs"/>
-                </a:defRPr>
-              </a:lvl7pPr>
-              <a:lvl8pPr marL="3200400" indent="0" algn="ctr" defTabSz="914400" rtl="0" eaLnBrk="1" latinLnBrk="0" hangingPunct="1">
-                <a:lnSpc>
-                  <a:spcPct val="90000"/>
-                </a:lnSpc>
-                <a:spcBef>
-                  <a:spcPts val="500"/>
-                </a:spcBef>
-                <a:buFont typeface="Arial" panose="020B0604020202020204" pitchFamily="34" charset="0"/>
-                <a:buNone/>
-                <a:defRPr sz="1600" kern="1200">
-                  <a:solidFill>
-                    <a:schemeClr val="tx1"/>
-                  </a:solidFill>
-                  <a:latin typeface="+mn-lt"/>
-                  <a:ea typeface="+mn-ea"/>
-                  <a:cs typeface="+mn-cs"/>
-                </a:defRPr>
-              </a:lvl8pPr>
-              <a:lvl9pPr marL="3657600" indent="0" algn="ctr" defTabSz="914400" rtl="0" eaLnBrk="1" latinLnBrk="0" hangingPunct="1">
-                <a:lnSpc>
-                  <a:spcPct val="90000"/>
-                </a:lnSpc>
-                <a:spcBef>
-                  <a:spcPts val="500"/>
-                </a:spcBef>
-                <a:buFont typeface="Arial" panose="020B0604020202020204" pitchFamily="34" charset="0"/>
-                <a:buNone/>
-                <a:defRPr sz="1600" kern="1200">
-                  <a:solidFill>
-                    <a:schemeClr val="tx1"/>
-                  </a:solidFill>
-                  <a:latin typeface="+mn-lt"/>
-                  <a:ea typeface="+mn-ea"/>
-                  <a:cs typeface="+mn-cs"/>
-                </a:defRPr>
-              </a:lvl9pPr>
-            </a:lstStyle>
-            <a:p>
-              <a:r>
-                <a:rPr lang="en-US" dirty="0"/>
-                <a:t>Repository Layer</a:t>
-              </a:r>
-            </a:p>
-          </p:txBody>
-        </p:sp>
-        <p:sp>
-          <p:nvSpPr>
             <p:cNvPr id="19" name="Subtitle 2">
               <a:extLst>
                 <a:ext uri="{FF2B5EF4-FFF2-40B4-BE49-F238E27FC236}">
@@ -5215,7 +5018,7 @@
           </p:nvSpPr>
           <p:spPr>
             <a:xfrm>
-              <a:off x="1900192" y="2755206"/>
+              <a:off x="3426415" y="2222086"/>
               <a:ext cx="2588682" cy="481492"/>
             </a:xfrm>
             <a:prstGeom prst="rect">
@@ -5422,7 +5225,7 @@
           </p:nvSpPr>
           <p:spPr>
             <a:xfrm>
-              <a:off x="5076599" y="2753521"/>
+              <a:off x="6216961" y="2222086"/>
               <a:ext cx="2588682" cy="481492"/>
             </a:xfrm>
             <a:prstGeom prst="rect">
@@ -5629,8 +5432,8 @@
           </p:nvSpPr>
           <p:spPr>
             <a:xfrm>
-              <a:off x="8155114" y="2755206"/>
-              <a:ext cx="2588682" cy="481492"/>
+              <a:off x="8925240" y="2222086"/>
+              <a:ext cx="2080363" cy="481492"/>
             </a:xfrm>
             <a:prstGeom prst="rect">
               <a:avLst/>
@@ -5835,10 +5638,10 @@
         </p:nvGrpSpPr>
         <p:grpSpPr>
           <a:xfrm>
-            <a:off x="925030" y="1953511"/>
-            <a:ext cx="10022078" cy="1191491"/>
-            <a:chOff x="1103122" y="2109354"/>
-            <a:chExt cx="10022078" cy="1191491"/>
+            <a:off x="1589171" y="1980630"/>
+            <a:ext cx="9396607" cy="720530"/>
+            <a:chOff x="1728593" y="2109355"/>
+            <a:chExt cx="9396607" cy="720530"/>
           </a:xfrm>
         </p:grpSpPr>
         <p:sp>
@@ -5855,8 +5658,8 @@
           </p:nvSpPr>
           <p:spPr>
             <a:xfrm>
-              <a:off x="1728593" y="2109354"/>
-              <a:ext cx="9396607" cy="1191491"/>
+              <a:off x="1728593" y="2109355"/>
+              <a:ext cx="9396607" cy="720530"/>
             </a:xfrm>
             <a:prstGeom prst="rect">
               <a:avLst/>
@@ -5891,208 +5694,6 @@
         </p:sp>
         <p:sp>
           <p:nvSpPr>
-            <p:cNvPr id="27" name="Subtitle 2">
-              <a:extLst>
-                <a:ext uri="{FF2B5EF4-FFF2-40B4-BE49-F238E27FC236}">
-                  <a16:creationId xmlns:a16="http://schemas.microsoft.com/office/drawing/2014/main" id="{9E8F8D34-ACE5-79F8-24AA-D60849360B70}"/>
-                </a:ext>
-              </a:extLst>
-            </p:cNvPr>
-            <p:cNvSpPr txBox="1">
-              <a:spLocks/>
-            </p:cNvSpPr>
-            <p:nvPr/>
-          </p:nvSpPr>
-          <p:spPr>
-            <a:xfrm>
-              <a:off x="1103122" y="2147393"/>
-              <a:ext cx="2699907" cy="515941"/>
-            </a:xfrm>
-            <a:prstGeom prst="rect">
-              <a:avLst/>
-            </a:prstGeom>
-            <a:ln w="25400">
-              <a:noFill/>
-            </a:ln>
-          </p:spPr>
-          <p:txBody>
-            <a:bodyPr vert="horz" lIns="91440" tIns="45720" rIns="91440" bIns="45720" rtlCol="0">
-              <a:normAutofit/>
-            </a:bodyPr>
-            <a:lstStyle>
-              <a:lvl1pPr marL="0" indent="0" algn="ctr" defTabSz="914400" rtl="0" eaLnBrk="1" latinLnBrk="0" hangingPunct="1">
-                <a:lnSpc>
-                  <a:spcPct val="90000"/>
-                </a:lnSpc>
-                <a:spcBef>
-                  <a:spcPts val="1000"/>
-                </a:spcBef>
-                <a:buFont typeface="Arial" panose="020B0604020202020204" pitchFamily="34" charset="0"/>
-                <a:buNone/>
-                <a:defRPr sz="2400" kern="1200">
-                  <a:solidFill>
-                    <a:schemeClr val="tx1"/>
-                  </a:solidFill>
-                  <a:latin typeface="+mn-lt"/>
-                  <a:ea typeface="+mn-ea"/>
-                  <a:cs typeface="+mn-cs"/>
-                </a:defRPr>
-              </a:lvl1pPr>
-              <a:lvl2pPr marL="457200" indent="0" algn="ctr" defTabSz="914400" rtl="0" eaLnBrk="1" latinLnBrk="0" hangingPunct="1">
-                <a:lnSpc>
-                  <a:spcPct val="90000"/>
-                </a:lnSpc>
-                <a:spcBef>
-                  <a:spcPts val="500"/>
-                </a:spcBef>
-                <a:buFont typeface="Arial" panose="020B0604020202020204" pitchFamily="34" charset="0"/>
-                <a:buNone/>
-                <a:defRPr sz="2000" kern="1200">
-                  <a:solidFill>
-                    <a:schemeClr val="tx1"/>
-                  </a:solidFill>
-                  <a:latin typeface="+mn-lt"/>
-                  <a:ea typeface="+mn-ea"/>
-                  <a:cs typeface="+mn-cs"/>
-                </a:defRPr>
-              </a:lvl2pPr>
-              <a:lvl3pPr marL="914400" indent="0" algn="ctr" defTabSz="914400" rtl="0" eaLnBrk="1" latinLnBrk="0" hangingPunct="1">
-                <a:lnSpc>
-                  <a:spcPct val="90000"/>
-                </a:lnSpc>
-                <a:spcBef>
-                  <a:spcPts val="500"/>
-                </a:spcBef>
-                <a:buFont typeface="Arial" panose="020B0604020202020204" pitchFamily="34" charset="0"/>
-                <a:buNone/>
-                <a:defRPr sz="1800" kern="1200">
-                  <a:solidFill>
-                    <a:schemeClr val="tx1"/>
-                  </a:solidFill>
-                  <a:latin typeface="+mn-lt"/>
-                  <a:ea typeface="+mn-ea"/>
-                  <a:cs typeface="+mn-cs"/>
-                </a:defRPr>
-              </a:lvl3pPr>
-              <a:lvl4pPr marL="1371600" indent="0" algn="ctr" defTabSz="914400" rtl="0" eaLnBrk="1" latinLnBrk="0" hangingPunct="1">
-                <a:lnSpc>
-                  <a:spcPct val="90000"/>
-                </a:lnSpc>
-                <a:spcBef>
-                  <a:spcPts val="500"/>
-                </a:spcBef>
-                <a:buFont typeface="Arial" panose="020B0604020202020204" pitchFamily="34" charset="0"/>
-                <a:buNone/>
-                <a:defRPr sz="1600" kern="1200">
-                  <a:solidFill>
-                    <a:schemeClr val="tx1"/>
-                  </a:solidFill>
-                  <a:latin typeface="+mn-lt"/>
-                  <a:ea typeface="+mn-ea"/>
-                  <a:cs typeface="+mn-cs"/>
-                </a:defRPr>
-              </a:lvl4pPr>
-              <a:lvl5pPr marL="1828800" indent="0" algn="ctr" defTabSz="914400" rtl="0" eaLnBrk="1" latinLnBrk="0" hangingPunct="1">
-                <a:lnSpc>
-                  <a:spcPct val="90000"/>
-                </a:lnSpc>
-                <a:spcBef>
-                  <a:spcPts val="500"/>
-                </a:spcBef>
-                <a:buFont typeface="Arial" panose="020B0604020202020204" pitchFamily="34" charset="0"/>
-                <a:buNone/>
-                <a:defRPr sz="1600" kern="1200">
-                  <a:solidFill>
-                    <a:schemeClr val="tx1"/>
-                  </a:solidFill>
-                  <a:latin typeface="+mn-lt"/>
-                  <a:ea typeface="+mn-ea"/>
-                  <a:cs typeface="+mn-cs"/>
-                </a:defRPr>
-              </a:lvl5pPr>
-              <a:lvl6pPr marL="2286000" indent="0" algn="ctr" defTabSz="914400" rtl="0" eaLnBrk="1" latinLnBrk="0" hangingPunct="1">
-                <a:lnSpc>
-                  <a:spcPct val="90000"/>
-                </a:lnSpc>
-                <a:spcBef>
-                  <a:spcPts val="500"/>
-                </a:spcBef>
-                <a:buFont typeface="Arial" panose="020B0604020202020204" pitchFamily="34" charset="0"/>
-                <a:buNone/>
-                <a:defRPr sz="1600" kern="1200">
-                  <a:solidFill>
-                    <a:schemeClr val="tx1"/>
-                  </a:solidFill>
-                  <a:latin typeface="+mn-lt"/>
-                  <a:ea typeface="+mn-ea"/>
-                  <a:cs typeface="+mn-cs"/>
-                </a:defRPr>
-              </a:lvl6pPr>
-              <a:lvl7pPr marL="2743200" indent="0" algn="ctr" defTabSz="914400" rtl="0" eaLnBrk="1" latinLnBrk="0" hangingPunct="1">
-                <a:lnSpc>
-                  <a:spcPct val="90000"/>
-                </a:lnSpc>
-                <a:spcBef>
-                  <a:spcPts val="500"/>
-                </a:spcBef>
-                <a:buFont typeface="Arial" panose="020B0604020202020204" pitchFamily="34" charset="0"/>
-                <a:buNone/>
-                <a:defRPr sz="1600" kern="1200">
-                  <a:solidFill>
-                    <a:schemeClr val="tx1"/>
-                  </a:solidFill>
-                  <a:latin typeface="+mn-lt"/>
-                  <a:ea typeface="+mn-ea"/>
-                  <a:cs typeface="+mn-cs"/>
-                </a:defRPr>
-              </a:lvl7pPr>
-              <a:lvl8pPr marL="3200400" indent="0" algn="ctr" defTabSz="914400" rtl="0" eaLnBrk="1" latinLnBrk="0" hangingPunct="1">
-                <a:lnSpc>
-                  <a:spcPct val="90000"/>
-                </a:lnSpc>
-                <a:spcBef>
-                  <a:spcPts val="500"/>
-                </a:spcBef>
-                <a:buFont typeface="Arial" panose="020B0604020202020204" pitchFamily="34" charset="0"/>
-                <a:buNone/>
-                <a:defRPr sz="1600" kern="1200">
-                  <a:solidFill>
-                    <a:schemeClr val="tx1"/>
-                  </a:solidFill>
-                  <a:latin typeface="+mn-lt"/>
-                  <a:ea typeface="+mn-ea"/>
-                  <a:cs typeface="+mn-cs"/>
-                </a:defRPr>
-              </a:lvl8pPr>
-              <a:lvl9pPr marL="3657600" indent="0" algn="ctr" defTabSz="914400" rtl="0" eaLnBrk="1" latinLnBrk="0" hangingPunct="1">
-                <a:lnSpc>
-                  <a:spcPct val="90000"/>
-                </a:lnSpc>
-                <a:spcBef>
-                  <a:spcPts val="500"/>
-                </a:spcBef>
-                <a:buFont typeface="Arial" panose="020B0604020202020204" pitchFamily="34" charset="0"/>
-                <a:buNone/>
-                <a:defRPr sz="1600" kern="1200">
-                  <a:solidFill>
-                    <a:schemeClr val="tx1"/>
-                  </a:solidFill>
-                  <a:latin typeface="+mn-lt"/>
-                  <a:ea typeface="+mn-ea"/>
-                  <a:cs typeface="+mn-cs"/>
-                </a:defRPr>
-              </a:lvl9pPr>
-            </a:lstStyle>
-            <a:p>
-              <a:r>
-                <a:rPr lang="en-US" dirty="0"/>
-                <a:t>Data Layer</a:t>
-              </a:r>
-            </a:p>
-          </p:txBody>
-        </p:sp>
-        <p:sp>
-          <p:nvSpPr>
             <p:cNvPr id="28" name="Subtitle 2">
               <a:extLst>
                 <a:ext uri="{FF2B5EF4-FFF2-40B4-BE49-F238E27FC236}">
@@ -6107,7 +5708,7 @@
           </p:nvSpPr>
           <p:spPr>
             <a:xfrm>
-              <a:off x="3200266" y="2682606"/>
+              <a:off x="3341435" y="2203396"/>
               <a:ext cx="2588682" cy="481492"/>
             </a:xfrm>
             <a:prstGeom prst="rect">
@@ -6313,7 +5914,7 @@
           </p:nvSpPr>
           <p:spPr>
             <a:xfrm>
-              <a:off x="6376673" y="2701675"/>
+              <a:off x="6338003" y="2203396"/>
               <a:ext cx="2588682" cy="481492"/>
             </a:xfrm>
             <a:prstGeom prst="rect">
@@ -6518,10 +6119,10 @@
         </p:nvGrpSpPr>
         <p:grpSpPr>
           <a:xfrm>
-            <a:off x="925030" y="486319"/>
-            <a:ext cx="10027811" cy="1191491"/>
-            <a:chOff x="1097389" y="2109354"/>
-            <a:chExt cx="10027811" cy="1191491"/>
+            <a:off x="1587764" y="948772"/>
+            <a:ext cx="9396607" cy="850143"/>
+            <a:chOff x="1728593" y="2109354"/>
+            <a:chExt cx="9396607" cy="850143"/>
           </a:xfrm>
         </p:grpSpPr>
         <p:sp>
@@ -6539,7 +6140,7 @@
           <p:spPr>
             <a:xfrm>
               <a:off x="1728593" y="2109354"/>
-              <a:ext cx="9396607" cy="1191491"/>
+              <a:ext cx="9396607" cy="850143"/>
             </a:xfrm>
             <a:prstGeom prst="rect">
               <a:avLst/>
@@ -6588,8 +6189,8 @@
           </p:nvSpPr>
           <p:spPr>
             <a:xfrm>
-              <a:off x="1097389" y="2148562"/>
-              <a:ext cx="2699907" cy="515941"/>
+              <a:off x="1730716" y="2215623"/>
+              <a:ext cx="1643656" cy="692652"/>
             </a:xfrm>
             <a:prstGeom prst="rect">
               <a:avLst/>
@@ -6600,7 +6201,7 @@
           </p:spPr>
           <p:txBody>
             <a:bodyPr vert="horz" lIns="91440" tIns="45720" rIns="91440" bIns="45720" rtlCol="0">
-              <a:normAutofit/>
+              <a:normAutofit fontScale="92500" lnSpcReduction="10000"/>
             </a:bodyPr>
             <a:lstStyle>
               <a:lvl1pPr marL="0" indent="0" algn="ctr" defTabSz="914400" rtl="0" eaLnBrk="1" latinLnBrk="0" hangingPunct="1">
@@ -6767,9 +6368,17 @@
               </a:lvl9pPr>
             </a:lstStyle>
             <a:p>
+              <a:pPr algn="l"/>
               <a:r>
                 <a:rPr lang="en-US" dirty="0"/>
-                <a:t>UI Layer</a:t>
+                <a:t>Presentation</a:t>
+              </a:r>
+              <a:br>
+                <a:rPr lang="en-US" dirty="0"/>
+              </a:br>
+              <a:r>
+                <a:rPr lang="en-US" dirty="0"/>
+                <a:t>Layer</a:t>
               </a:r>
             </a:p>
           </p:txBody>
@@ -6790,7 +6399,7 @@
           </p:nvSpPr>
           <p:spPr>
             <a:xfrm>
-              <a:off x="3300683" y="2728650"/>
+              <a:off x="3374372" y="2279121"/>
               <a:ext cx="2588682" cy="481492"/>
             </a:xfrm>
             <a:prstGeom prst="rect">
@@ -6996,7 +6605,7 @@
           </p:nvSpPr>
           <p:spPr>
             <a:xfrm>
-              <a:off x="6410430" y="2710828"/>
+              <a:off x="6370940" y="2287093"/>
               <a:ext cx="2588682" cy="481492"/>
             </a:xfrm>
             <a:prstGeom prst="rect">
@@ -7187,6 +6796,1121 @@
           </p:txBody>
         </p:sp>
       </p:grpSp>
+      <p:sp>
+        <p:nvSpPr>
+          <p:cNvPr id="2" name="Subtitle 2">
+            <a:extLst>
+              <a:ext uri="{FF2B5EF4-FFF2-40B4-BE49-F238E27FC236}">
+                <a16:creationId xmlns:a16="http://schemas.microsoft.com/office/drawing/2014/main" id="{8B90D171-4959-AB8E-B116-C82BE34E8C4A}"/>
+              </a:ext>
+            </a:extLst>
+          </p:cNvPr>
+          <p:cNvSpPr txBox="1">
+            <a:spLocks/>
+          </p:cNvSpPr>
+          <p:nvPr/>
+        </p:nvSpPr>
+        <p:spPr>
+          <a:xfrm>
+            <a:off x="1589171" y="1982314"/>
+            <a:ext cx="1133008" cy="718845"/>
+          </a:xfrm>
+          <a:prstGeom prst="rect">
+            <a:avLst/>
+          </a:prstGeom>
+          <a:ln w="25400">
+            <a:noFill/>
+          </a:ln>
+        </p:spPr>
+        <p:txBody>
+          <a:bodyPr vert="horz" lIns="91440" tIns="45720" rIns="91440" bIns="45720" rtlCol="0">
+            <a:normAutofit fontScale="92500"/>
+          </a:bodyPr>
+          <a:lstStyle>
+            <a:lvl1pPr marL="0" indent="0" algn="ctr" defTabSz="914400" rtl="0" eaLnBrk="1" latinLnBrk="0" hangingPunct="1">
+              <a:lnSpc>
+                <a:spcPct val="90000"/>
+              </a:lnSpc>
+              <a:spcBef>
+                <a:spcPts val="1000"/>
+              </a:spcBef>
+              <a:buFont typeface="Arial" panose="020B0604020202020204" pitchFamily="34" charset="0"/>
+              <a:buNone/>
+              <a:defRPr sz="2400" kern="1200">
+                <a:solidFill>
+                  <a:schemeClr val="tx1"/>
+                </a:solidFill>
+                <a:latin typeface="+mn-lt"/>
+                <a:ea typeface="+mn-ea"/>
+                <a:cs typeface="+mn-cs"/>
+              </a:defRPr>
+            </a:lvl1pPr>
+            <a:lvl2pPr marL="457200" indent="0" algn="ctr" defTabSz="914400" rtl="0" eaLnBrk="1" latinLnBrk="0" hangingPunct="1">
+              <a:lnSpc>
+                <a:spcPct val="90000"/>
+              </a:lnSpc>
+              <a:spcBef>
+                <a:spcPts val="500"/>
+              </a:spcBef>
+              <a:buFont typeface="Arial" panose="020B0604020202020204" pitchFamily="34" charset="0"/>
+              <a:buNone/>
+              <a:defRPr sz="2000" kern="1200">
+                <a:solidFill>
+                  <a:schemeClr val="tx1"/>
+                </a:solidFill>
+                <a:latin typeface="+mn-lt"/>
+                <a:ea typeface="+mn-ea"/>
+                <a:cs typeface="+mn-cs"/>
+              </a:defRPr>
+            </a:lvl2pPr>
+            <a:lvl3pPr marL="914400" indent="0" algn="ctr" defTabSz="914400" rtl="0" eaLnBrk="1" latinLnBrk="0" hangingPunct="1">
+              <a:lnSpc>
+                <a:spcPct val="90000"/>
+              </a:lnSpc>
+              <a:spcBef>
+                <a:spcPts val="500"/>
+              </a:spcBef>
+              <a:buFont typeface="Arial" panose="020B0604020202020204" pitchFamily="34" charset="0"/>
+              <a:buNone/>
+              <a:defRPr sz="1800" kern="1200">
+                <a:solidFill>
+                  <a:schemeClr val="tx1"/>
+                </a:solidFill>
+                <a:latin typeface="+mn-lt"/>
+                <a:ea typeface="+mn-ea"/>
+                <a:cs typeface="+mn-cs"/>
+              </a:defRPr>
+            </a:lvl3pPr>
+            <a:lvl4pPr marL="1371600" indent="0" algn="ctr" defTabSz="914400" rtl="0" eaLnBrk="1" latinLnBrk="0" hangingPunct="1">
+              <a:lnSpc>
+                <a:spcPct val="90000"/>
+              </a:lnSpc>
+              <a:spcBef>
+                <a:spcPts val="500"/>
+              </a:spcBef>
+              <a:buFont typeface="Arial" panose="020B0604020202020204" pitchFamily="34" charset="0"/>
+              <a:buNone/>
+              <a:defRPr sz="1600" kern="1200">
+                <a:solidFill>
+                  <a:schemeClr val="tx1"/>
+                </a:solidFill>
+                <a:latin typeface="+mn-lt"/>
+                <a:ea typeface="+mn-ea"/>
+                <a:cs typeface="+mn-cs"/>
+              </a:defRPr>
+            </a:lvl4pPr>
+            <a:lvl5pPr marL="1828800" indent="0" algn="ctr" defTabSz="914400" rtl="0" eaLnBrk="1" latinLnBrk="0" hangingPunct="1">
+              <a:lnSpc>
+                <a:spcPct val="90000"/>
+              </a:lnSpc>
+              <a:spcBef>
+                <a:spcPts val="500"/>
+              </a:spcBef>
+              <a:buFont typeface="Arial" panose="020B0604020202020204" pitchFamily="34" charset="0"/>
+              <a:buNone/>
+              <a:defRPr sz="1600" kern="1200">
+                <a:solidFill>
+                  <a:schemeClr val="tx1"/>
+                </a:solidFill>
+                <a:latin typeface="+mn-lt"/>
+                <a:ea typeface="+mn-ea"/>
+                <a:cs typeface="+mn-cs"/>
+              </a:defRPr>
+            </a:lvl5pPr>
+            <a:lvl6pPr marL="2286000" indent="0" algn="ctr" defTabSz="914400" rtl="0" eaLnBrk="1" latinLnBrk="0" hangingPunct="1">
+              <a:lnSpc>
+                <a:spcPct val="90000"/>
+              </a:lnSpc>
+              <a:spcBef>
+                <a:spcPts val="500"/>
+              </a:spcBef>
+              <a:buFont typeface="Arial" panose="020B0604020202020204" pitchFamily="34" charset="0"/>
+              <a:buNone/>
+              <a:defRPr sz="1600" kern="1200">
+                <a:solidFill>
+                  <a:schemeClr val="tx1"/>
+                </a:solidFill>
+                <a:latin typeface="+mn-lt"/>
+                <a:ea typeface="+mn-ea"/>
+                <a:cs typeface="+mn-cs"/>
+              </a:defRPr>
+            </a:lvl6pPr>
+            <a:lvl7pPr marL="2743200" indent="0" algn="ctr" defTabSz="914400" rtl="0" eaLnBrk="1" latinLnBrk="0" hangingPunct="1">
+              <a:lnSpc>
+                <a:spcPct val="90000"/>
+              </a:lnSpc>
+              <a:spcBef>
+                <a:spcPts val="500"/>
+              </a:spcBef>
+              <a:buFont typeface="Arial" panose="020B0604020202020204" pitchFamily="34" charset="0"/>
+              <a:buNone/>
+              <a:defRPr sz="1600" kern="1200">
+                <a:solidFill>
+                  <a:schemeClr val="tx1"/>
+                </a:solidFill>
+                <a:latin typeface="+mn-lt"/>
+                <a:ea typeface="+mn-ea"/>
+                <a:cs typeface="+mn-cs"/>
+              </a:defRPr>
+            </a:lvl7pPr>
+            <a:lvl8pPr marL="3200400" indent="0" algn="ctr" defTabSz="914400" rtl="0" eaLnBrk="1" latinLnBrk="0" hangingPunct="1">
+              <a:lnSpc>
+                <a:spcPct val="90000"/>
+              </a:lnSpc>
+              <a:spcBef>
+                <a:spcPts val="500"/>
+              </a:spcBef>
+              <a:buFont typeface="Arial" panose="020B0604020202020204" pitchFamily="34" charset="0"/>
+              <a:buNone/>
+              <a:defRPr sz="1600" kern="1200">
+                <a:solidFill>
+                  <a:schemeClr val="tx1"/>
+                </a:solidFill>
+                <a:latin typeface="+mn-lt"/>
+                <a:ea typeface="+mn-ea"/>
+                <a:cs typeface="+mn-cs"/>
+              </a:defRPr>
+            </a:lvl8pPr>
+            <a:lvl9pPr marL="3657600" indent="0" algn="ctr" defTabSz="914400" rtl="0" eaLnBrk="1" latinLnBrk="0" hangingPunct="1">
+              <a:lnSpc>
+                <a:spcPct val="90000"/>
+              </a:lnSpc>
+              <a:spcBef>
+                <a:spcPts val="500"/>
+              </a:spcBef>
+              <a:buFont typeface="Arial" panose="020B0604020202020204" pitchFamily="34" charset="0"/>
+              <a:buNone/>
+              <a:defRPr sz="1600" kern="1200">
+                <a:solidFill>
+                  <a:schemeClr val="tx1"/>
+                </a:solidFill>
+                <a:latin typeface="+mn-lt"/>
+                <a:ea typeface="+mn-ea"/>
+                <a:cs typeface="+mn-cs"/>
+              </a:defRPr>
+            </a:lvl9pPr>
+          </a:lstStyle>
+          <a:p>
+            <a:pPr algn="l"/>
+            <a:r>
+              <a:rPr lang="en-US" dirty="0"/>
+              <a:t>Domain</a:t>
+            </a:r>
+            <a:br>
+              <a:rPr lang="en-US" dirty="0"/>
+            </a:br>
+            <a:r>
+              <a:rPr lang="en-US" dirty="0"/>
+              <a:t>Layer</a:t>
+            </a:r>
+          </a:p>
+        </p:txBody>
+      </p:sp>
+      <p:sp>
+        <p:nvSpPr>
+          <p:cNvPr id="4" name="Subtitle 2">
+            <a:extLst>
+              <a:ext uri="{FF2B5EF4-FFF2-40B4-BE49-F238E27FC236}">
+                <a16:creationId xmlns:a16="http://schemas.microsoft.com/office/drawing/2014/main" id="{9205E3F1-8447-632E-26FD-A1ABE191493D}"/>
+              </a:ext>
+            </a:extLst>
+          </p:cNvPr>
+          <p:cNvSpPr txBox="1">
+            <a:spLocks/>
+          </p:cNvSpPr>
+          <p:nvPr/>
+        </p:nvSpPr>
+        <p:spPr>
+          <a:xfrm>
+            <a:off x="1594867" y="3810552"/>
+            <a:ext cx="1535293" cy="718845"/>
+          </a:xfrm>
+          <a:prstGeom prst="rect">
+            <a:avLst/>
+          </a:prstGeom>
+          <a:ln w="25400">
+            <a:noFill/>
+          </a:ln>
+        </p:spPr>
+        <p:txBody>
+          <a:bodyPr vert="horz" lIns="91440" tIns="45720" rIns="91440" bIns="45720" rtlCol="0">
+            <a:normAutofit lnSpcReduction="10000"/>
+          </a:bodyPr>
+          <a:lstStyle>
+            <a:lvl1pPr marL="0" indent="0" algn="ctr" defTabSz="914400" rtl="0" eaLnBrk="1" latinLnBrk="0" hangingPunct="1">
+              <a:lnSpc>
+                <a:spcPct val="90000"/>
+              </a:lnSpc>
+              <a:spcBef>
+                <a:spcPts val="1000"/>
+              </a:spcBef>
+              <a:buFont typeface="Arial" panose="020B0604020202020204" pitchFamily="34" charset="0"/>
+              <a:buNone/>
+              <a:defRPr sz="2400" kern="1200">
+                <a:solidFill>
+                  <a:schemeClr val="tx1"/>
+                </a:solidFill>
+                <a:latin typeface="+mn-lt"/>
+                <a:ea typeface="+mn-ea"/>
+                <a:cs typeface="+mn-cs"/>
+              </a:defRPr>
+            </a:lvl1pPr>
+            <a:lvl2pPr marL="457200" indent="0" algn="ctr" defTabSz="914400" rtl="0" eaLnBrk="1" latinLnBrk="0" hangingPunct="1">
+              <a:lnSpc>
+                <a:spcPct val="90000"/>
+              </a:lnSpc>
+              <a:spcBef>
+                <a:spcPts val="500"/>
+              </a:spcBef>
+              <a:buFont typeface="Arial" panose="020B0604020202020204" pitchFamily="34" charset="0"/>
+              <a:buNone/>
+              <a:defRPr sz="2000" kern="1200">
+                <a:solidFill>
+                  <a:schemeClr val="tx1"/>
+                </a:solidFill>
+                <a:latin typeface="+mn-lt"/>
+                <a:ea typeface="+mn-ea"/>
+                <a:cs typeface="+mn-cs"/>
+              </a:defRPr>
+            </a:lvl2pPr>
+            <a:lvl3pPr marL="914400" indent="0" algn="ctr" defTabSz="914400" rtl="0" eaLnBrk="1" latinLnBrk="0" hangingPunct="1">
+              <a:lnSpc>
+                <a:spcPct val="90000"/>
+              </a:lnSpc>
+              <a:spcBef>
+                <a:spcPts val="500"/>
+              </a:spcBef>
+              <a:buFont typeface="Arial" panose="020B0604020202020204" pitchFamily="34" charset="0"/>
+              <a:buNone/>
+              <a:defRPr sz="1800" kern="1200">
+                <a:solidFill>
+                  <a:schemeClr val="tx1"/>
+                </a:solidFill>
+                <a:latin typeface="+mn-lt"/>
+                <a:ea typeface="+mn-ea"/>
+                <a:cs typeface="+mn-cs"/>
+              </a:defRPr>
+            </a:lvl3pPr>
+            <a:lvl4pPr marL="1371600" indent="0" algn="ctr" defTabSz="914400" rtl="0" eaLnBrk="1" latinLnBrk="0" hangingPunct="1">
+              <a:lnSpc>
+                <a:spcPct val="90000"/>
+              </a:lnSpc>
+              <a:spcBef>
+                <a:spcPts val="500"/>
+              </a:spcBef>
+              <a:buFont typeface="Arial" panose="020B0604020202020204" pitchFamily="34" charset="0"/>
+              <a:buNone/>
+              <a:defRPr sz="1600" kern="1200">
+                <a:solidFill>
+                  <a:schemeClr val="tx1"/>
+                </a:solidFill>
+                <a:latin typeface="+mn-lt"/>
+                <a:ea typeface="+mn-ea"/>
+                <a:cs typeface="+mn-cs"/>
+              </a:defRPr>
+            </a:lvl4pPr>
+            <a:lvl5pPr marL="1828800" indent="0" algn="ctr" defTabSz="914400" rtl="0" eaLnBrk="1" latinLnBrk="0" hangingPunct="1">
+              <a:lnSpc>
+                <a:spcPct val="90000"/>
+              </a:lnSpc>
+              <a:spcBef>
+                <a:spcPts val="500"/>
+              </a:spcBef>
+              <a:buFont typeface="Arial" panose="020B0604020202020204" pitchFamily="34" charset="0"/>
+              <a:buNone/>
+              <a:defRPr sz="1600" kern="1200">
+                <a:solidFill>
+                  <a:schemeClr val="tx1"/>
+                </a:solidFill>
+                <a:latin typeface="+mn-lt"/>
+                <a:ea typeface="+mn-ea"/>
+                <a:cs typeface="+mn-cs"/>
+              </a:defRPr>
+            </a:lvl5pPr>
+            <a:lvl6pPr marL="2286000" indent="0" algn="ctr" defTabSz="914400" rtl="0" eaLnBrk="1" latinLnBrk="0" hangingPunct="1">
+              <a:lnSpc>
+                <a:spcPct val="90000"/>
+              </a:lnSpc>
+              <a:spcBef>
+                <a:spcPts val="500"/>
+              </a:spcBef>
+              <a:buFont typeface="Arial" panose="020B0604020202020204" pitchFamily="34" charset="0"/>
+              <a:buNone/>
+              <a:defRPr sz="1600" kern="1200">
+                <a:solidFill>
+                  <a:schemeClr val="tx1"/>
+                </a:solidFill>
+                <a:latin typeface="+mn-lt"/>
+                <a:ea typeface="+mn-ea"/>
+                <a:cs typeface="+mn-cs"/>
+              </a:defRPr>
+            </a:lvl6pPr>
+            <a:lvl7pPr marL="2743200" indent="0" algn="ctr" defTabSz="914400" rtl="0" eaLnBrk="1" latinLnBrk="0" hangingPunct="1">
+              <a:lnSpc>
+                <a:spcPct val="90000"/>
+              </a:lnSpc>
+              <a:spcBef>
+                <a:spcPts val="500"/>
+              </a:spcBef>
+              <a:buFont typeface="Arial" panose="020B0604020202020204" pitchFamily="34" charset="0"/>
+              <a:buNone/>
+              <a:defRPr sz="1600" kern="1200">
+                <a:solidFill>
+                  <a:schemeClr val="tx1"/>
+                </a:solidFill>
+                <a:latin typeface="+mn-lt"/>
+                <a:ea typeface="+mn-ea"/>
+                <a:cs typeface="+mn-cs"/>
+              </a:defRPr>
+            </a:lvl7pPr>
+            <a:lvl8pPr marL="3200400" indent="0" algn="ctr" defTabSz="914400" rtl="0" eaLnBrk="1" latinLnBrk="0" hangingPunct="1">
+              <a:lnSpc>
+                <a:spcPct val="90000"/>
+              </a:lnSpc>
+              <a:spcBef>
+                <a:spcPts val="500"/>
+              </a:spcBef>
+              <a:buFont typeface="Arial" panose="020B0604020202020204" pitchFamily="34" charset="0"/>
+              <a:buNone/>
+              <a:defRPr sz="1600" kern="1200">
+                <a:solidFill>
+                  <a:schemeClr val="tx1"/>
+                </a:solidFill>
+                <a:latin typeface="+mn-lt"/>
+                <a:ea typeface="+mn-ea"/>
+                <a:cs typeface="+mn-cs"/>
+              </a:defRPr>
+            </a:lvl8pPr>
+            <a:lvl9pPr marL="3657600" indent="0" algn="ctr" defTabSz="914400" rtl="0" eaLnBrk="1" latinLnBrk="0" hangingPunct="1">
+              <a:lnSpc>
+                <a:spcPct val="90000"/>
+              </a:lnSpc>
+              <a:spcBef>
+                <a:spcPts val="500"/>
+              </a:spcBef>
+              <a:buFont typeface="Arial" panose="020B0604020202020204" pitchFamily="34" charset="0"/>
+              <a:buNone/>
+              <a:defRPr sz="1600" kern="1200">
+                <a:solidFill>
+                  <a:schemeClr val="tx1"/>
+                </a:solidFill>
+                <a:latin typeface="+mn-lt"/>
+                <a:ea typeface="+mn-ea"/>
+                <a:cs typeface="+mn-cs"/>
+              </a:defRPr>
+            </a:lvl9pPr>
+          </a:lstStyle>
+          <a:p>
+            <a:pPr algn="l"/>
+            <a:r>
+              <a:rPr lang="en-US" dirty="0"/>
+              <a:t>Repository</a:t>
+            </a:r>
+            <a:br>
+              <a:rPr lang="en-US" dirty="0"/>
+            </a:br>
+            <a:r>
+              <a:rPr lang="en-US" dirty="0"/>
+              <a:t>Layer</a:t>
+            </a:r>
+          </a:p>
+        </p:txBody>
+      </p:sp>
+      <p:grpSp>
+        <p:nvGrpSpPr>
+          <p:cNvPr id="8" name="Group 7">
+            <a:extLst>
+              <a:ext uri="{FF2B5EF4-FFF2-40B4-BE49-F238E27FC236}">
+                <a16:creationId xmlns:a16="http://schemas.microsoft.com/office/drawing/2014/main" id="{FAE19FEE-FDCD-8ACD-7CB0-8DA7705CB3A2}"/>
+              </a:ext>
+            </a:extLst>
+          </p:cNvPr>
+          <p:cNvGrpSpPr/>
+          <p:nvPr/>
+        </p:nvGrpSpPr>
+        <p:grpSpPr>
+          <a:xfrm>
+            <a:off x="1589171" y="2857868"/>
+            <a:ext cx="9396607" cy="720530"/>
+            <a:chOff x="1728593" y="2109355"/>
+            <a:chExt cx="9396607" cy="720530"/>
+          </a:xfrm>
+        </p:grpSpPr>
+        <p:sp>
+          <p:nvSpPr>
+            <p:cNvPr id="11" name="Rectangle 10">
+              <a:extLst>
+                <a:ext uri="{FF2B5EF4-FFF2-40B4-BE49-F238E27FC236}">
+                  <a16:creationId xmlns:a16="http://schemas.microsoft.com/office/drawing/2014/main" id="{8CA35CD0-55CF-F9A1-4F70-A191B8C415E2}"/>
+                </a:ext>
+              </a:extLst>
+            </p:cNvPr>
+            <p:cNvSpPr/>
+            <p:nvPr/>
+          </p:nvSpPr>
+          <p:spPr>
+            <a:xfrm>
+              <a:off x="1728593" y="2109355"/>
+              <a:ext cx="9396607" cy="720530"/>
+            </a:xfrm>
+            <a:prstGeom prst="rect">
+              <a:avLst/>
+            </a:prstGeom>
+            <a:noFill/>
+            <a:ln w="25400"/>
+          </p:spPr>
+          <p:style>
+            <a:lnRef idx="2">
+              <a:schemeClr val="accent1">
+                <a:shade val="50000"/>
+              </a:schemeClr>
+            </a:lnRef>
+            <a:fillRef idx="1">
+              <a:schemeClr val="accent1"/>
+            </a:fillRef>
+            <a:effectRef idx="0">
+              <a:schemeClr val="accent1"/>
+            </a:effectRef>
+            <a:fontRef idx="minor">
+              <a:schemeClr val="lt1"/>
+            </a:fontRef>
+          </p:style>
+          <p:txBody>
+            <a:bodyPr rtlCol="0" anchor="ctr"/>
+            <a:lstStyle/>
+            <a:p>
+              <a:pPr algn="ctr"/>
+              <a:endParaRPr lang="en-US"/>
+            </a:p>
+          </p:txBody>
+        </p:sp>
+        <p:sp>
+          <p:nvSpPr>
+            <p:cNvPr id="22" name="Subtitle 2">
+              <a:extLst>
+                <a:ext uri="{FF2B5EF4-FFF2-40B4-BE49-F238E27FC236}">
+                  <a16:creationId xmlns:a16="http://schemas.microsoft.com/office/drawing/2014/main" id="{9EFEA67F-34F4-6817-1FFD-7C3B42F0BC0E}"/>
+                </a:ext>
+              </a:extLst>
+            </p:cNvPr>
+            <p:cNvSpPr txBox="1">
+              <a:spLocks/>
+            </p:cNvSpPr>
+            <p:nvPr/>
+          </p:nvSpPr>
+          <p:spPr>
+            <a:xfrm>
+              <a:off x="3341435" y="2203396"/>
+              <a:ext cx="2588682" cy="481492"/>
+            </a:xfrm>
+            <a:prstGeom prst="rect">
+              <a:avLst/>
+            </a:prstGeom>
+            <a:ln w="25400">
+              <a:solidFill>
+                <a:schemeClr val="accent1">
+                  <a:shade val="50000"/>
+                </a:schemeClr>
+              </a:solidFill>
+            </a:ln>
+          </p:spPr>
+          <p:txBody>
+            <a:bodyPr vert="horz" lIns="91440" tIns="45720" rIns="91440" bIns="45720" rtlCol="0">
+              <a:normAutofit/>
+            </a:bodyPr>
+            <a:lstStyle>
+              <a:lvl1pPr marL="0" indent="0" algn="ctr" defTabSz="914400" rtl="0" eaLnBrk="1" latinLnBrk="0" hangingPunct="1">
+                <a:lnSpc>
+                  <a:spcPct val="90000"/>
+                </a:lnSpc>
+                <a:spcBef>
+                  <a:spcPts val="1000"/>
+                </a:spcBef>
+                <a:buFont typeface="Arial" panose="020B0604020202020204" pitchFamily="34" charset="0"/>
+                <a:buNone/>
+                <a:defRPr sz="2400" kern="1200">
+                  <a:solidFill>
+                    <a:schemeClr val="tx1"/>
+                  </a:solidFill>
+                  <a:latin typeface="+mn-lt"/>
+                  <a:ea typeface="+mn-ea"/>
+                  <a:cs typeface="+mn-cs"/>
+                </a:defRPr>
+              </a:lvl1pPr>
+              <a:lvl2pPr marL="457200" indent="0" algn="ctr" defTabSz="914400" rtl="0" eaLnBrk="1" latinLnBrk="0" hangingPunct="1">
+                <a:lnSpc>
+                  <a:spcPct val="90000"/>
+                </a:lnSpc>
+                <a:spcBef>
+                  <a:spcPts val="500"/>
+                </a:spcBef>
+                <a:buFont typeface="Arial" panose="020B0604020202020204" pitchFamily="34" charset="0"/>
+                <a:buNone/>
+                <a:defRPr sz="2000" kern="1200">
+                  <a:solidFill>
+                    <a:schemeClr val="tx1"/>
+                  </a:solidFill>
+                  <a:latin typeface="+mn-lt"/>
+                  <a:ea typeface="+mn-ea"/>
+                  <a:cs typeface="+mn-cs"/>
+                </a:defRPr>
+              </a:lvl2pPr>
+              <a:lvl3pPr marL="914400" indent="0" algn="ctr" defTabSz="914400" rtl="0" eaLnBrk="1" latinLnBrk="0" hangingPunct="1">
+                <a:lnSpc>
+                  <a:spcPct val="90000"/>
+                </a:lnSpc>
+                <a:spcBef>
+                  <a:spcPts val="500"/>
+                </a:spcBef>
+                <a:buFont typeface="Arial" panose="020B0604020202020204" pitchFamily="34" charset="0"/>
+                <a:buNone/>
+                <a:defRPr sz="1800" kern="1200">
+                  <a:solidFill>
+                    <a:schemeClr val="tx1"/>
+                  </a:solidFill>
+                  <a:latin typeface="+mn-lt"/>
+                  <a:ea typeface="+mn-ea"/>
+                  <a:cs typeface="+mn-cs"/>
+                </a:defRPr>
+              </a:lvl3pPr>
+              <a:lvl4pPr marL="1371600" indent="0" algn="ctr" defTabSz="914400" rtl="0" eaLnBrk="1" latinLnBrk="0" hangingPunct="1">
+                <a:lnSpc>
+                  <a:spcPct val="90000"/>
+                </a:lnSpc>
+                <a:spcBef>
+                  <a:spcPts val="500"/>
+                </a:spcBef>
+                <a:buFont typeface="Arial" panose="020B0604020202020204" pitchFamily="34" charset="0"/>
+                <a:buNone/>
+                <a:defRPr sz="1600" kern="1200">
+                  <a:solidFill>
+                    <a:schemeClr val="tx1"/>
+                  </a:solidFill>
+                  <a:latin typeface="+mn-lt"/>
+                  <a:ea typeface="+mn-ea"/>
+                  <a:cs typeface="+mn-cs"/>
+                </a:defRPr>
+              </a:lvl4pPr>
+              <a:lvl5pPr marL="1828800" indent="0" algn="ctr" defTabSz="914400" rtl="0" eaLnBrk="1" latinLnBrk="0" hangingPunct="1">
+                <a:lnSpc>
+                  <a:spcPct val="90000"/>
+                </a:lnSpc>
+                <a:spcBef>
+                  <a:spcPts val="500"/>
+                </a:spcBef>
+                <a:buFont typeface="Arial" panose="020B0604020202020204" pitchFamily="34" charset="0"/>
+                <a:buNone/>
+                <a:defRPr sz="1600" kern="1200">
+                  <a:solidFill>
+                    <a:schemeClr val="tx1"/>
+                  </a:solidFill>
+                  <a:latin typeface="+mn-lt"/>
+                  <a:ea typeface="+mn-ea"/>
+                  <a:cs typeface="+mn-cs"/>
+                </a:defRPr>
+              </a:lvl5pPr>
+              <a:lvl6pPr marL="2286000" indent="0" algn="ctr" defTabSz="914400" rtl="0" eaLnBrk="1" latinLnBrk="0" hangingPunct="1">
+                <a:lnSpc>
+                  <a:spcPct val="90000"/>
+                </a:lnSpc>
+                <a:spcBef>
+                  <a:spcPts val="500"/>
+                </a:spcBef>
+                <a:buFont typeface="Arial" panose="020B0604020202020204" pitchFamily="34" charset="0"/>
+                <a:buNone/>
+                <a:defRPr sz="1600" kern="1200">
+                  <a:solidFill>
+                    <a:schemeClr val="tx1"/>
+                  </a:solidFill>
+                  <a:latin typeface="+mn-lt"/>
+                  <a:ea typeface="+mn-ea"/>
+                  <a:cs typeface="+mn-cs"/>
+                </a:defRPr>
+              </a:lvl6pPr>
+              <a:lvl7pPr marL="2743200" indent="0" algn="ctr" defTabSz="914400" rtl="0" eaLnBrk="1" latinLnBrk="0" hangingPunct="1">
+                <a:lnSpc>
+                  <a:spcPct val="90000"/>
+                </a:lnSpc>
+                <a:spcBef>
+                  <a:spcPts val="500"/>
+                </a:spcBef>
+                <a:buFont typeface="Arial" panose="020B0604020202020204" pitchFamily="34" charset="0"/>
+                <a:buNone/>
+                <a:defRPr sz="1600" kern="1200">
+                  <a:solidFill>
+                    <a:schemeClr val="tx1"/>
+                  </a:solidFill>
+                  <a:latin typeface="+mn-lt"/>
+                  <a:ea typeface="+mn-ea"/>
+                  <a:cs typeface="+mn-cs"/>
+                </a:defRPr>
+              </a:lvl7pPr>
+              <a:lvl8pPr marL="3200400" indent="0" algn="ctr" defTabSz="914400" rtl="0" eaLnBrk="1" latinLnBrk="0" hangingPunct="1">
+                <a:lnSpc>
+                  <a:spcPct val="90000"/>
+                </a:lnSpc>
+                <a:spcBef>
+                  <a:spcPts val="500"/>
+                </a:spcBef>
+                <a:buFont typeface="Arial" panose="020B0604020202020204" pitchFamily="34" charset="0"/>
+                <a:buNone/>
+                <a:defRPr sz="1600" kern="1200">
+                  <a:solidFill>
+                    <a:schemeClr val="tx1"/>
+                  </a:solidFill>
+                  <a:latin typeface="+mn-lt"/>
+                  <a:ea typeface="+mn-ea"/>
+                  <a:cs typeface="+mn-cs"/>
+                </a:defRPr>
+              </a:lvl8pPr>
+              <a:lvl9pPr marL="3657600" indent="0" algn="ctr" defTabSz="914400" rtl="0" eaLnBrk="1" latinLnBrk="0" hangingPunct="1">
+                <a:lnSpc>
+                  <a:spcPct val="90000"/>
+                </a:lnSpc>
+                <a:spcBef>
+                  <a:spcPts val="500"/>
+                </a:spcBef>
+                <a:buFont typeface="Arial" panose="020B0604020202020204" pitchFamily="34" charset="0"/>
+                <a:buNone/>
+                <a:defRPr sz="1600" kern="1200">
+                  <a:solidFill>
+                    <a:schemeClr val="tx1"/>
+                  </a:solidFill>
+                  <a:latin typeface="+mn-lt"/>
+                  <a:ea typeface="+mn-ea"/>
+                  <a:cs typeface="+mn-cs"/>
+                </a:defRPr>
+              </a:lvl9pPr>
+            </a:lstStyle>
+            <a:p>
+              <a:r>
+                <a:rPr lang="en-US" dirty="0"/>
+                <a:t>Database classes</a:t>
+              </a:r>
+            </a:p>
+          </p:txBody>
+        </p:sp>
+        <p:sp>
+          <p:nvSpPr>
+            <p:cNvPr id="24" name="Subtitle 2">
+              <a:extLst>
+                <a:ext uri="{FF2B5EF4-FFF2-40B4-BE49-F238E27FC236}">
+                  <a16:creationId xmlns:a16="http://schemas.microsoft.com/office/drawing/2014/main" id="{90C75E7E-0A8B-866F-A1B5-EE621B1A4D40}"/>
+                </a:ext>
+              </a:extLst>
+            </p:cNvPr>
+            <p:cNvSpPr txBox="1">
+              <a:spLocks/>
+            </p:cNvSpPr>
+            <p:nvPr/>
+          </p:nvSpPr>
+          <p:spPr>
+            <a:xfrm>
+              <a:off x="6338003" y="2203396"/>
+              <a:ext cx="2588682" cy="481492"/>
+            </a:xfrm>
+            <a:prstGeom prst="rect">
+              <a:avLst/>
+            </a:prstGeom>
+            <a:ln w="25400">
+              <a:solidFill>
+                <a:schemeClr val="accent1">
+                  <a:shade val="50000"/>
+                </a:schemeClr>
+              </a:solidFill>
+            </a:ln>
+          </p:spPr>
+          <p:txBody>
+            <a:bodyPr vert="horz" lIns="91440" tIns="45720" rIns="91440" bIns="45720" rtlCol="0">
+              <a:normAutofit/>
+            </a:bodyPr>
+            <a:lstStyle>
+              <a:lvl1pPr marL="0" indent="0" algn="ctr" defTabSz="914400" rtl="0" eaLnBrk="1" latinLnBrk="0" hangingPunct="1">
+                <a:lnSpc>
+                  <a:spcPct val="90000"/>
+                </a:lnSpc>
+                <a:spcBef>
+                  <a:spcPts val="1000"/>
+                </a:spcBef>
+                <a:buFont typeface="Arial" panose="020B0604020202020204" pitchFamily="34" charset="0"/>
+                <a:buNone/>
+                <a:defRPr sz="2400" kern="1200">
+                  <a:solidFill>
+                    <a:schemeClr val="tx1"/>
+                  </a:solidFill>
+                  <a:latin typeface="+mn-lt"/>
+                  <a:ea typeface="+mn-ea"/>
+                  <a:cs typeface="+mn-cs"/>
+                </a:defRPr>
+              </a:lvl1pPr>
+              <a:lvl2pPr marL="457200" indent="0" algn="ctr" defTabSz="914400" rtl="0" eaLnBrk="1" latinLnBrk="0" hangingPunct="1">
+                <a:lnSpc>
+                  <a:spcPct val="90000"/>
+                </a:lnSpc>
+                <a:spcBef>
+                  <a:spcPts val="500"/>
+                </a:spcBef>
+                <a:buFont typeface="Arial" panose="020B0604020202020204" pitchFamily="34" charset="0"/>
+                <a:buNone/>
+                <a:defRPr sz="2000" kern="1200">
+                  <a:solidFill>
+                    <a:schemeClr val="tx1"/>
+                  </a:solidFill>
+                  <a:latin typeface="+mn-lt"/>
+                  <a:ea typeface="+mn-ea"/>
+                  <a:cs typeface="+mn-cs"/>
+                </a:defRPr>
+              </a:lvl2pPr>
+              <a:lvl3pPr marL="914400" indent="0" algn="ctr" defTabSz="914400" rtl="0" eaLnBrk="1" latinLnBrk="0" hangingPunct="1">
+                <a:lnSpc>
+                  <a:spcPct val="90000"/>
+                </a:lnSpc>
+                <a:spcBef>
+                  <a:spcPts val="500"/>
+                </a:spcBef>
+                <a:buFont typeface="Arial" panose="020B0604020202020204" pitchFamily="34" charset="0"/>
+                <a:buNone/>
+                <a:defRPr sz="1800" kern="1200">
+                  <a:solidFill>
+                    <a:schemeClr val="tx1"/>
+                  </a:solidFill>
+                  <a:latin typeface="+mn-lt"/>
+                  <a:ea typeface="+mn-ea"/>
+                  <a:cs typeface="+mn-cs"/>
+                </a:defRPr>
+              </a:lvl3pPr>
+              <a:lvl4pPr marL="1371600" indent="0" algn="ctr" defTabSz="914400" rtl="0" eaLnBrk="1" latinLnBrk="0" hangingPunct="1">
+                <a:lnSpc>
+                  <a:spcPct val="90000"/>
+                </a:lnSpc>
+                <a:spcBef>
+                  <a:spcPts val="500"/>
+                </a:spcBef>
+                <a:buFont typeface="Arial" panose="020B0604020202020204" pitchFamily="34" charset="0"/>
+                <a:buNone/>
+                <a:defRPr sz="1600" kern="1200">
+                  <a:solidFill>
+                    <a:schemeClr val="tx1"/>
+                  </a:solidFill>
+                  <a:latin typeface="+mn-lt"/>
+                  <a:ea typeface="+mn-ea"/>
+                  <a:cs typeface="+mn-cs"/>
+                </a:defRPr>
+              </a:lvl4pPr>
+              <a:lvl5pPr marL="1828800" indent="0" algn="ctr" defTabSz="914400" rtl="0" eaLnBrk="1" latinLnBrk="0" hangingPunct="1">
+                <a:lnSpc>
+                  <a:spcPct val="90000"/>
+                </a:lnSpc>
+                <a:spcBef>
+                  <a:spcPts val="500"/>
+                </a:spcBef>
+                <a:buFont typeface="Arial" panose="020B0604020202020204" pitchFamily="34" charset="0"/>
+                <a:buNone/>
+                <a:defRPr sz="1600" kern="1200">
+                  <a:solidFill>
+                    <a:schemeClr val="tx1"/>
+                  </a:solidFill>
+                  <a:latin typeface="+mn-lt"/>
+                  <a:ea typeface="+mn-ea"/>
+                  <a:cs typeface="+mn-cs"/>
+                </a:defRPr>
+              </a:lvl5pPr>
+              <a:lvl6pPr marL="2286000" indent="0" algn="ctr" defTabSz="914400" rtl="0" eaLnBrk="1" latinLnBrk="0" hangingPunct="1">
+                <a:lnSpc>
+                  <a:spcPct val="90000"/>
+                </a:lnSpc>
+                <a:spcBef>
+                  <a:spcPts val="500"/>
+                </a:spcBef>
+                <a:buFont typeface="Arial" panose="020B0604020202020204" pitchFamily="34" charset="0"/>
+                <a:buNone/>
+                <a:defRPr sz="1600" kern="1200">
+                  <a:solidFill>
+                    <a:schemeClr val="tx1"/>
+                  </a:solidFill>
+                  <a:latin typeface="+mn-lt"/>
+                  <a:ea typeface="+mn-ea"/>
+                  <a:cs typeface="+mn-cs"/>
+                </a:defRPr>
+              </a:lvl6pPr>
+              <a:lvl7pPr marL="2743200" indent="0" algn="ctr" defTabSz="914400" rtl="0" eaLnBrk="1" latinLnBrk="0" hangingPunct="1">
+                <a:lnSpc>
+                  <a:spcPct val="90000"/>
+                </a:lnSpc>
+                <a:spcBef>
+                  <a:spcPts val="500"/>
+                </a:spcBef>
+                <a:buFont typeface="Arial" panose="020B0604020202020204" pitchFamily="34" charset="0"/>
+                <a:buNone/>
+                <a:defRPr sz="1600" kern="1200">
+                  <a:solidFill>
+                    <a:schemeClr val="tx1"/>
+                  </a:solidFill>
+                  <a:latin typeface="+mn-lt"/>
+                  <a:ea typeface="+mn-ea"/>
+                  <a:cs typeface="+mn-cs"/>
+                </a:defRPr>
+              </a:lvl7pPr>
+              <a:lvl8pPr marL="3200400" indent="0" algn="ctr" defTabSz="914400" rtl="0" eaLnBrk="1" latinLnBrk="0" hangingPunct="1">
+                <a:lnSpc>
+                  <a:spcPct val="90000"/>
+                </a:lnSpc>
+                <a:spcBef>
+                  <a:spcPts val="500"/>
+                </a:spcBef>
+                <a:buFont typeface="Arial" panose="020B0604020202020204" pitchFamily="34" charset="0"/>
+                <a:buNone/>
+                <a:defRPr sz="1600" kern="1200">
+                  <a:solidFill>
+                    <a:schemeClr val="tx1"/>
+                  </a:solidFill>
+                  <a:latin typeface="+mn-lt"/>
+                  <a:ea typeface="+mn-ea"/>
+                  <a:cs typeface="+mn-cs"/>
+                </a:defRPr>
+              </a:lvl8pPr>
+              <a:lvl9pPr marL="3657600" indent="0" algn="ctr" defTabSz="914400" rtl="0" eaLnBrk="1" latinLnBrk="0" hangingPunct="1">
+                <a:lnSpc>
+                  <a:spcPct val="90000"/>
+                </a:lnSpc>
+                <a:spcBef>
+                  <a:spcPts val="500"/>
+                </a:spcBef>
+                <a:buFont typeface="Arial" panose="020B0604020202020204" pitchFamily="34" charset="0"/>
+                <a:buNone/>
+                <a:defRPr sz="1600" kern="1200">
+                  <a:solidFill>
+                    <a:schemeClr val="tx1"/>
+                  </a:solidFill>
+                  <a:latin typeface="+mn-lt"/>
+                  <a:ea typeface="+mn-ea"/>
+                  <a:cs typeface="+mn-cs"/>
+                </a:defRPr>
+              </a:lvl9pPr>
+            </a:lstStyle>
+            <a:p>
+              <a:r>
+                <a:rPr lang="en-US" dirty="0" err="1"/>
+                <a:t>Riverpod</a:t>
+              </a:r>
+              <a:r>
+                <a:rPr lang="en-US" dirty="0"/>
+                <a:t> providers</a:t>
+              </a:r>
+            </a:p>
+          </p:txBody>
+        </p:sp>
+      </p:grpSp>
+      <p:sp>
+        <p:nvSpPr>
+          <p:cNvPr id="30" name="Subtitle 2">
+            <a:extLst>
+              <a:ext uri="{FF2B5EF4-FFF2-40B4-BE49-F238E27FC236}">
+                <a16:creationId xmlns:a16="http://schemas.microsoft.com/office/drawing/2014/main" id="{7059CF34-6CBF-0751-AAE3-D95F1BF8E87C}"/>
+              </a:ext>
+            </a:extLst>
+          </p:cNvPr>
+          <p:cNvSpPr txBox="1">
+            <a:spLocks/>
+          </p:cNvSpPr>
+          <p:nvPr/>
+        </p:nvSpPr>
+        <p:spPr>
+          <a:xfrm>
+            <a:off x="1589171" y="2859552"/>
+            <a:ext cx="1133008" cy="718845"/>
+          </a:xfrm>
+          <a:prstGeom prst="rect">
+            <a:avLst/>
+          </a:prstGeom>
+          <a:ln w="25400">
+            <a:noFill/>
+          </a:ln>
+        </p:spPr>
+        <p:txBody>
+          <a:bodyPr vert="horz" lIns="91440" tIns="45720" rIns="91440" bIns="45720" rtlCol="0">
+            <a:normAutofit lnSpcReduction="10000"/>
+          </a:bodyPr>
+          <a:lstStyle>
+            <a:lvl1pPr marL="0" indent="0" algn="ctr" defTabSz="914400" rtl="0" eaLnBrk="1" latinLnBrk="0" hangingPunct="1">
+              <a:lnSpc>
+                <a:spcPct val="90000"/>
+              </a:lnSpc>
+              <a:spcBef>
+                <a:spcPts val="1000"/>
+              </a:spcBef>
+              <a:buFont typeface="Arial" panose="020B0604020202020204" pitchFamily="34" charset="0"/>
+              <a:buNone/>
+              <a:defRPr sz="2400" kern="1200">
+                <a:solidFill>
+                  <a:schemeClr val="tx1"/>
+                </a:solidFill>
+                <a:latin typeface="+mn-lt"/>
+                <a:ea typeface="+mn-ea"/>
+                <a:cs typeface="+mn-cs"/>
+              </a:defRPr>
+            </a:lvl1pPr>
+            <a:lvl2pPr marL="457200" indent="0" algn="ctr" defTabSz="914400" rtl="0" eaLnBrk="1" latinLnBrk="0" hangingPunct="1">
+              <a:lnSpc>
+                <a:spcPct val="90000"/>
+              </a:lnSpc>
+              <a:spcBef>
+                <a:spcPts val="500"/>
+              </a:spcBef>
+              <a:buFont typeface="Arial" panose="020B0604020202020204" pitchFamily="34" charset="0"/>
+              <a:buNone/>
+              <a:defRPr sz="2000" kern="1200">
+                <a:solidFill>
+                  <a:schemeClr val="tx1"/>
+                </a:solidFill>
+                <a:latin typeface="+mn-lt"/>
+                <a:ea typeface="+mn-ea"/>
+                <a:cs typeface="+mn-cs"/>
+              </a:defRPr>
+            </a:lvl2pPr>
+            <a:lvl3pPr marL="914400" indent="0" algn="ctr" defTabSz="914400" rtl="0" eaLnBrk="1" latinLnBrk="0" hangingPunct="1">
+              <a:lnSpc>
+                <a:spcPct val="90000"/>
+              </a:lnSpc>
+              <a:spcBef>
+                <a:spcPts val="500"/>
+              </a:spcBef>
+              <a:buFont typeface="Arial" panose="020B0604020202020204" pitchFamily="34" charset="0"/>
+              <a:buNone/>
+              <a:defRPr sz="1800" kern="1200">
+                <a:solidFill>
+                  <a:schemeClr val="tx1"/>
+                </a:solidFill>
+                <a:latin typeface="+mn-lt"/>
+                <a:ea typeface="+mn-ea"/>
+                <a:cs typeface="+mn-cs"/>
+              </a:defRPr>
+            </a:lvl3pPr>
+            <a:lvl4pPr marL="1371600" indent="0" algn="ctr" defTabSz="914400" rtl="0" eaLnBrk="1" latinLnBrk="0" hangingPunct="1">
+              <a:lnSpc>
+                <a:spcPct val="90000"/>
+              </a:lnSpc>
+              <a:spcBef>
+                <a:spcPts val="500"/>
+              </a:spcBef>
+              <a:buFont typeface="Arial" panose="020B0604020202020204" pitchFamily="34" charset="0"/>
+              <a:buNone/>
+              <a:defRPr sz="1600" kern="1200">
+                <a:solidFill>
+                  <a:schemeClr val="tx1"/>
+                </a:solidFill>
+                <a:latin typeface="+mn-lt"/>
+                <a:ea typeface="+mn-ea"/>
+                <a:cs typeface="+mn-cs"/>
+              </a:defRPr>
+            </a:lvl4pPr>
+            <a:lvl5pPr marL="1828800" indent="0" algn="ctr" defTabSz="914400" rtl="0" eaLnBrk="1" latinLnBrk="0" hangingPunct="1">
+              <a:lnSpc>
+                <a:spcPct val="90000"/>
+              </a:lnSpc>
+              <a:spcBef>
+                <a:spcPts val="500"/>
+              </a:spcBef>
+              <a:buFont typeface="Arial" panose="020B0604020202020204" pitchFamily="34" charset="0"/>
+              <a:buNone/>
+              <a:defRPr sz="1600" kern="1200">
+                <a:solidFill>
+                  <a:schemeClr val="tx1"/>
+                </a:solidFill>
+                <a:latin typeface="+mn-lt"/>
+                <a:ea typeface="+mn-ea"/>
+                <a:cs typeface="+mn-cs"/>
+              </a:defRPr>
+            </a:lvl5pPr>
+            <a:lvl6pPr marL="2286000" indent="0" algn="ctr" defTabSz="914400" rtl="0" eaLnBrk="1" latinLnBrk="0" hangingPunct="1">
+              <a:lnSpc>
+                <a:spcPct val="90000"/>
+              </a:lnSpc>
+              <a:spcBef>
+                <a:spcPts val="500"/>
+              </a:spcBef>
+              <a:buFont typeface="Arial" panose="020B0604020202020204" pitchFamily="34" charset="0"/>
+              <a:buNone/>
+              <a:defRPr sz="1600" kern="1200">
+                <a:solidFill>
+                  <a:schemeClr val="tx1"/>
+                </a:solidFill>
+                <a:latin typeface="+mn-lt"/>
+                <a:ea typeface="+mn-ea"/>
+                <a:cs typeface="+mn-cs"/>
+              </a:defRPr>
+            </a:lvl6pPr>
+            <a:lvl7pPr marL="2743200" indent="0" algn="ctr" defTabSz="914400" rtl="0" eaLnBrk="1" latinLnBrk="0" hangingPunct="1">
+              <a:lnSpc>
+                <a:spcPct val="90000"/>
+              </a:lnSpc>
+              <a:spcBef>
+                <a:spcPts val="500"/>
+              </a:spcBef>
+              <a:buFont typeface="Arial" panose="020B0604020202020204" pitchFamily="34" charset="0"/>
+              <a:buNone/>
+              <a:defRPr sz="1600" kern="1200">
+                <a:solidFill>
+                  <a:schemeClr val="tx1"/>
+                </a:solidFill>
+                <a:latin typeface="+mn-lt"/>
+                <a:ea typeface="+mn-ea"/>
+                <a:cs typeface="+mn-cs"/>
+              </a:defRPr>
+            </a:lvl7pPr>
+            <a:lvl8pPr marL="3200400" indent="0" algn="ctr" defTabSz="914400" rtl="0" eaLnBrk="1" latinLnBrk="0" hangingPunct="1">
+              <a:lnSpc>
+                <a:spcPct val="90000"/>
+              </a:lnSpc>
+              <a:spcBef>
+                <a:spcPts val="500"/>
+              </a:spcBef>
+              <a:buFont typeface="Arial" panose="020B0604020202020204" pitchFamily="34" charset="0"/>
+              <a:buNone/>
+              <a:defRPr sz="1600" kern="1200">
+                <a:solidFill>
+                  <a:schemeClr val="tx1"/>
+                </a:solidFill>
+                <a:latin typeface="+mn-lt"/>
+                <a:ea typeface="+mn-ea"/>
+                <a:cs typeface="+mn-cs"/>
+              </a:defRPr>
+            </a:lvl8pPr>
+            <a:lvl9pPr marL="3657600" indent="0" algn="ctr" defTabSz="914400" rtl="0" eaLnBrk="1" latinLnBrk="0" hangingPunct="1">
+              <a:lnSpc>
+                <a:spcPct val="90000"/>
+              </a:lnSpc>
+              <a:spcBef>
+                <a:spcPts val="500"/>
+              </a:spcBef>
+              <a:buFont typeface="Arial" panose="020B0604020202020204" pitchFamily="34" charset="0"/>
+              <a:buNone/>
+              <a:defRPr sz="1600" kern="1200">
+                <a:solidFill>
+                  <a:schemeClr val="tx1"/>
+                </a:solidFill>
+                <a:latin typeface="+mn-lt"/>
+                <a:ea typeface="+mn-ea"/>
+                <a:cs typeface="+mn-cs"/>
+              </a:defRPr>
+            </a:lvl9pPr>
+          </a:lstStyle>
+          <a:p>
+            <a:pPr algn="l"/>
+            <a:r>
+              <a:rPr lang="en-US" dirty="0"/>
+              <a:t>Data</a:t>
+            </a:r>
+            <a:br>
+              <a:rPr lang="en-US" dirty="0"/>
+            </a:br>
+            <a:r>
+              <a:rPr lang="en-US" dirty="0"/>
+              <a:t>Layer</a:t>
+            </a:r>
+          </a:p>
+        </p:txBody>
+      </p:sp>
     </p:spTree>
     <p:extLst>
       <p:ext uri="{BB962C8B-B14F-4D97-AF65-F5344CB8AC3E}">

</xml_diff>